<commit_message>
Đồng bộ slide bìa bài giảng điện tử Toán 10, 11, 12: chỉ ghi số tiết và tiết PPCT, bỏ dòng tên bộ sách
Co-Authored-By: Claude Opus 5.5 <noreply@anthropic.com>
</commit_message>
<xml_diff>
--- a/mon/toan/slide/lop12/BaiGiangDienTu_TOAN12_BaiTapCuoiChuong2_T40-41.pptx
+++ b/mon/toan/slide/lop12/BaiGiangDienTu_TOAN12_BaiTapCuoiChuong2_T40-41.pptx
@@ -5686,22 +5686,6 @@
                 </a:solidFill>
                 <a:latin typeface="Calibri"/>
               </a:rPr>
-              <a:t>Toán 12 – Kết nối tri thức với cuộc sống (SGK tập một, tr.73 – 74)</a:t>
-            </a:r>
-          </a:p>
-          <a:p>
-            <a:pPr algn="l">
-              <a:spcAft>
-                <a:spcPts val="800"/>
-              </a:spcAft>
-            </a:pPr>
-            <a:r>
-              <a:rPr sz="2200">
-                <a:solidFill>
-                  <a:srgbClr val="E0E7FF"/>
-                </a:solidFill>
-                <a:latin typeface="Calibri"/>
-              </a:rPr>
               <a:t>2 tiết: T40 – T41</a:t>
             </a:r>
           </a:p>

</xml_diff>